<commit_message>
Title sync: SI header/visible title, graphical abstract, README (nine systems, 88542 rows, audit 588/0/7, 60pp); SI stale Section 4 -> 10 ref
</commit_message>
<xml_diff>
--- a/Graphical_Abstract_fe_surrogate.pptx
+++ b/Graphical_Abstract_fe_surrogate.pptx
@@ -3122,7 +3122,7 @@
                 </a:solidFill>
                 <a:latin typeface="Arial"/>
               </a:rPr>
-              <a:t>Machine-Learning Surrogates for CALPHAD Phase-Fraction Prediction</a:t>
+              <a:t>Trustworthy High-Throughput Screening</a:t>
             </a:r>
           </a:p>
         </p:txBody>
@@ -3161,7 +3161,7 @@
                 </a:solidFill>
                 <a:latin typeface="Arial"/>
               </a:rPr>
-              <a:t>Simplex constraints, spatial generalization, and the regressor–detector gap in five Fe-based ternary systems</a:t>
+              <a:t>with simplex-constrained surrogates for CALPHAD phase-fraction prediction in five Fe-based ternary systems</a:t>
             </a:r>
           </a:p>
         </p:txBody>
@@ -12537,7 +12537,7 @@
                 </a:solidFill>
                 <a:latin typeface="Arial"/>
               </a:rPr>
-              <a:t>Fixed-protocol benchmark · 6 heads + 2 mechanism probes · 4 baselines · 5 systems · 44,397 equilibria · seeds 42 / 123 / 2024 · negative results reported in full</a:t>
+              <a:t>Fixed-protocol benchmark · 6 heads + 2 mechanism probes · 4 baselines · 5 ternary + 4 extension systems · 88,542 equilibria · seeds 42 / 123 / 2024 · negative results reported in full</a:t>
             </a:r>
           </a:p>
         </p:txBody>

</xml_diff>

<commit_message>
Title finalized: Trustworthy -> Validated across tex/SI/docx/GA/README/cover letter; GA subtitle now nine alloy systems; audit 590/0/7, builds 60pp+7pp
</commit_message>
<xml_diff>
--- a/Graphical_Abstract_fe_surrogate.pptx
+++ b/Graphical_Abstract_fe_surrogate.pptx
@@ -3122,7 +3122,7 @@
                 </a:solidFill>
                 <a:latin typeface="Arial"/>
               </a:rPr>
-              <a:t>Trustworthy High-Throughput Screening</a:t>
+              <a:t>Validated High-Throughput Screening</a:t>
             </a:r>
           </a:p>
         </p:txBody>
@@ -3161,7 +3161,7 @@
                 </a:solidFill>
                 <a:latin typeface="Arial"/>
               </a:rPr>
-              <a:t>with simplex-constrained surrogates for CALPHAD phase-fraction prediction in five Fe-based ternary systems</a:t>
+              <a:t>with simplex-constrained surrogates for CALPHAD phase-fraction prediction in nine alloy systems</a:t>
             </a:r>
           </a:p>
         </p:txBody>

</xml_diff>

<commit_message>
Graphical abstract: nine-system scope, confirmatory gated-remedy outcome, deployment takeaway; verified numbers (holdout penalties, projection bound, confirmatory AUPRC)
</commit_message>
<xml_diff>
--- a/Graphical_Abstract_fe_surrogate.pptx
+++ b/Graphical_Abstract_fe_surrogate.pptx
@@ -3161,7 +3161,7 @@
                 </a:solidFill>
                 <a:latin typeface="Arial"/>
               </a:rPr>
-              <a:t>With Simplex-Constrained Surrogates for CALPHAD Phase-Fraction Prediction in Nine Alloy Systems</a:t>
+              <a:t>Simplex-constrained surrogates for CALPHAD phase-fraction prediction in nine alloy systems</a:t>
             </a:r>
           </a:p>
         </p:txBody>
@@ -3504,7 +3504,7 @@
                 </a:solidFill>
                 <a:latin typeface="Arial"/>
               </a:rPr>
-              <a:t>Five Fe-based ternary systems</a:t>
+              <a:t>Nine alloy systems</a:t>
             </a:r>
           </a:p>
         </p:txBody>
@@ -3543,7 +3543,7 @@
                 </a:solidFill>
                 <a:latin typeface="Arial"/>
               </a:rPr>
-              <a:t>Fe–Cr–Ni · Fe–Cr–Mn · Fe–Cr–Mo</a:t>
+              <a:t>five Fe ternaries · quaternary Fe–Cr–Ni–C</a:t>
             </a:r>
           </a:p>
           <a:p>
@@ -3559,7 +3559,7 @@
                 </a:solidFill>
                 <a:latin typeface="Arial"/>
               </a:rPr>
-              <a:t>Fe–Cr–V · Fe–Mn–Ni</a:t>
+              <a:t>carbide Fe–Cr–C · Fe-free Cr–Co–Ni, Cr–Ni–Mn</a:t>
             </a:r>
           </a:p>
         </p:txBody>
@@ -3572,7 +3572,7 @@
         </p:nvSpPr>
         <p:spPr>
           <a:xfrm>
-            <a:off x="512064" y="1956816"/>
+            <a:off x="512064" y="1938528"/>
             <a:ext cx="2331720" cy="146304"/>
           </a:xfrm>
           <a:prstGeom prst="rect">
@@ -3611,7 +3611,7 @@
         </p:nvSpPr>
         <p:spPr>
           <a:xfrm>
-            <a:off x="512064" y="2093976"/>
+            <a:off x="512064" y="2057400"/>
             <a:ext cx="2331720" cy="146304"/>
           </a:xfrm>
           <a:prstGeom prst="rect">
@@ -3637,7 +3637,7 @@
                 </a:solidFill>
                 <a:latin typeface="Arial"/>
               </a:rPr>
-              <a:t>44,397 validated equilibria · 3 seeds</a:t>
+              <a:t>88,542 mass-balance-validated equilibria</a:t>
             </a:r>
           </a:p>
         </p:txBody>
@@ -3650,7 +3650,7 @@
         </p:nvSpPr>
         <p:spPr>
           <a:xfrm>
-            <a:off x="512064" y="2231136"/>
+            <a:off x="512064" y="2194560"/>
             <a:ext cx="2331720" cy="146304"/>
           </a:xfrm>
           <a:prstGeom prst="rect">
@@ -5464,7 +5464,7 @@
         <p:spPr>
           <a:xfrm>
             <a:off x="393192" y="4791456"/>
-            <a:ext cx="3383280" cy="566928"/>
+            <a:ext cx="3383280" cy="713232"/>
           </a:xfrm>
           <a:prstGeom prst="roundRect">
             <a:avLst>
@@ -5551,7 +5551,101 @@
         <p:spPr>
           <a:xfrm>
             <a:off x="676656" y="4846320"/>
-            <a:ext cx="3017520" cy="219456"/>
+            <a:ext cx="3017520" cy="365760"/>
+          </a:xfrm>
+          <a:prstGeom prst="rect">
+            <a:avLst/>
+          </a:prstGeom>
+          <a:noFill/>
+        </p:spPr>
+        <p:txBody>
+          <a:bodyPr wrap="square" anchor="t" lIns="0" rIns="0" tIns="0" bIns="0">
+            <a:noAutofit/>
+          </a:bodyPr>
+          <a:lstStyle/>
+          <a:p>
+            <a:pPr algn="l">
+              <a:lnSpc>
+                <a:spcPct val="105000"/>
+              </a:lnSpc>
+            </a:pPr>
+            <a:r>
+              <a:rPr sz="850" b="1" i="0">
+                <a:solidFill>
+                  <a:srgbClr val="244276"/>
+                </a:solidFill>
+                <a:latin typeface="Arial"/>
+              </a:rPr>
+              <a:t>structural constraints: Σ ŷ = 1 exactly</a:t>
+            </a:r>
+          </a:p>
+          <a:p>
+            <a:pPr algn="l">
+              <a:lnSpc>
+                <a:spcPct val="105000"/>
+              </a:lnSpc>
+            </a:pPr>
+            <a:r>
+              <a:rPr sz="850" b="1" i="0">
+                <a:solidFill>
+                  <a:srgbClr val="244276"/>
+                </a:solidFill>
+                <a:latin typeface="Arial"/>
+              </a:rPr>
+              <a:t>projection recovers renorm within 1.3×10⁻⁴ MAE</a:t>
+            </a:r>
+          </a:p>
+        </p:txBody>
+      </p:sp>
+      <p:sp>
+        <p:nvSpPr>
+          <p:cNvPr id="61" name="TextBox 60"/>
+          <p:cNvSpPr txBox="1"/>
+          <p:nvPr/>
+        </p:nvSpPr>
+        <p:spPr>
+          <a:xfrm>
+            <a:off x="475488" y="5248656"/>
+            <a:ext cx="182880" cy="164592"/>
+          </a:xfrm>
+          <a:prstGeom prst="rect">
+            <a:avLst/>
+          </a:prstGeom>
+          <a:noFill/>
+        </p:spPr>
+        <p:txBody>
+          <a:bodyPr wrap="square" anchor="ctr" lIns="0" rIns="0" tIns="0" bIns="0">
+            <a:noAutofit/>
+          </a:bodyPr>
+          <a:lstStyle/>
+          <a:p>
+            <a:pPr algn="ctr">
+              <a:lnSpc>
+                <a:spcPct val="100000"/>
+              </a:lnSpc>
+            </a:pPr>
+            <a:r>
+              <a:rPr sz="1200" b="1" i="0">
+                <a:solidFill>
+                  <a:srgbClr val="B04A3A"/>
+                </a:solidFill>
+                <a:latin typeface="Arial"/>
+              </a:rPr>
+              <a:t>✗</a:t>
+            </a:r>
+          </a:p>
+        </p:txBody>
+      </p:sp>
+      <p:sp>
+        <p:nvSpPr>
+          <p:cNvPr id="62" name="TextBox 61"/>
+          <p:cNvSpPr txBox="1"/>
+          <p:nvPr/>
+        </p:nvSpPr>
+        <p:spPr>
+          <a:xfrm>
+            <a:off x="676656" y="5248656"/>
+            <a:ext cx="3017520" cy="182880"/>
           </a:xfrm>
           <a:prstGeom prst="rect">
             <a:avLst/>
@@ -5572,64 +5666,25 @@
             <a:r>
               <a:rPr sz="850" b="1" i="0">
                 <a:solidFill>
-                  <a:srgbClr val="244276"/>
+                  <a:srgbClr val="2B2B2B"/>
                 </a:solidFill>
                 <a:latin typeface="Arial"/>
               </a:rPr>
-              <a:t>structural constraints: Σ ŷ = 1 at no accuracy cost</a:t>
-            </a:r>
-          </a:p>
-        </p:txBody>
-      </p:sp>
-      <p:sp>
-        <p:nvSpPr>
-          <p:cNvPr id="61" name="TextBox 60"/>
+              <a:t>no single architecture wins all five systems</a:t>
+            </a:r>
+          </a:p>
+        </p:txBody>
+      </p:sp>
+      <p:sp>
+        <p:nvSpPr>
+          <p:cNvPr id="63" name="TextBox 62"/>
           <p:cNvSpPr txBox="1"/>
           <p:nvPr/>
         </p:nvSpPr>
         <p:spPr>
           <a:xfrm>
-            <a:off x="475488" y="5084064"/>
-            <a:ext cx="182880" cy="164592"/>
-          </a:xfrm>
-          <a:prstGeom prst="rect">
-            <a:avLst/>
-          </a:prstGeom>
-          <a:noFill/>
-        </p:spPr>
-        <p:txBody>
-          <a:bodyPr wrap="square" anchor="ctr" lIns="0" rIns="0" tIns="0" bIns="0">
-            <a:noAutofit/>
-          </a:bodyPr>
-          <a:lstStyle/>
-          <a:p>
-            <a:pPr algn="ctr">
-              <a:lnSpc>
-                <a:spcPct val="100000"/>
-              </a:lnSpc>
-            </a:pPr>
-            <a:r>
-              <a:rPr sz="1200" b="1" i="0">
-                <a:solidFill>
-                  <a:srgbClr val="B04A3A"/>
-                </a:solidFill>
-                <a:latin typeface="Arial"/>
-              </a:rPr>
-              <a:t>✗</a:t>
-            </a:r>
-          </a:p>
-        </p:txBody>
-      </p:sp>
-      <p:sp>
-        <p:nvSpPr>
-          <p:cNvPr id="62" name="TextBox 61"/>
-          <p:cNvSpPr txBox="1"/>
-          <p:nvPr/>
-        </p:nvSpPr>
-        <p:spPr>
-          <a:xfrm>
-            <a:off x="676656" y="5084064"/>
-            <a:ext cx="3017520" cy="219456"/>
+            <a:off x="512064" y="5559552"/>
+            <a:ext cx="2011680" cy="146304"/>
           </a:xfrm>
           <a:prstGeom prst="rect">
             <a:avLst/>
@@ -5648,45 +5703,6 @@
               </a:lnSpc>
             </a:pPr>
             <a:r>
-              <a:rPr sz="850" b="1" i="0">
-                <a:solidFill>
-                  <a:srgbClr val="2B2B2B"/>
-                </a:solidFill>
-                <a:latin typeface="Arial"/>
-              </a:rPr>
-              <a:t>no single architecture wins all five systems</a:t>
-            </a:r>
-          </a:p>
-        </p:txBody>
-      </p:sp>
-      <p:sp>
-        <p:nvSpPr>
-          <p:cNvPr id="63" name="TextBox 62"/>
-          <p:cNvSpPr txBox="1"/>
-          <p:nvPr/>
-        </p:nvSpPr>
-        <p:spPr>
-          <a:xfrm>
-            <a:off x="512064" y="5449824"/>
-            <a:ext cx="2011680" cy="146304"/>
-          </a:xfrm>
-          <a:prstGeom prst="rect">
-            <a:avLst/>
-          </a:prstGeom>
-          <a:noFill/>
-        </p:spPr>
-        <p:txBody>
-          <a:bodyPr wrap="square" anchor="t" lIns="0" rIns="0" tIns="0" bIns="0">
-            <a:noAutofit/>
-          </a:bodyPr>
-          <a:lstStyle/>
-          <a:p>
-            <a:pPr algn="l">
-              <a:lnSpc>
-                <a:spcPct val="100000"/>
-              </a:lnSpc>
-            </a:pPr>
-            <a:r>
               <a:rPr sz="800" b="1" i="0">
                 <a:solidFill>
                   <a:srgbClr val="5B6573"/>
@@ -5706,7 +5722,7 @@
         </p:nvSpPr>
         <p:spPr>
           <a:xfrm>
-            <a:off x="2560320" y="5486400"/>
+            <a:off x="2560320" y="5596128"/>
             <a:ext cx="128016" cy="64008"/>
           </a:xfrm>
           <a:prstGeom prst="rect">
@@ -5750,7 +5766,7 @@
         </p:nvSpPr>
         <p:spPr>
           <a:xfrm>
-            <a:off x="2706624" y="5449824"/>
+            <a:off x="2706624" y="5559552"/>
             <a:ext cx="384048" cy="128016"/>
           </a:xfrm>
           <a:prstGeom prst="rect">
@@ -5789,7 +5805,7 @@
         </p:nvSpPr>
         <p:spPr>
           <a:xfrm>
-            <a:off x="3072384" y="5486400"/>
+            <a:off x="3072384" y="5596128"/>
             <a:ext cx="128016" cy="64008"/>
           </a:xfrm>
           <a:prstGeom prst="rect">
@@ -5833,7 +5849,7 @@
         </p:nvSpPr>
         <p:spPr>
           <a:xfrm>
-            <a:off x="3218688" y="5449824"/>
+            <a:off x="3218688" y="5559552"/>
             <a:ext cx="502920" cy="128016"/>
           </a:xfrm>
           <a:prstGeom prst="rect">
@@ -5872,7 +5888,7 @@
         </p:nvSpPr>
         <p:spPr>
           <a:xfrm>
-            <a:off x="512064" y="5623560"/>
+            <a:off x="512064" y="5733288"/>
             <a:ext cx="777240" cy="128016"/>
           </a:xfrm>
           <a:prstGeom prst="rect">
@@ -5911,7 +5927,7 @@
         </p:nvSpPr>
         <p:spPr>
           <a:xfrm>
-            <a:off x="1316736" y="5641848"/>
+            <a:off x="1316736" y="5751575"/>
             <a:ext cx="1737360" cy="45720"/>
           </a:xfrm>
           <a:prstGeom prst="rect">
@@ -5955,7 +5971,7 @@
         </p:nvSpPr>
         <p:spPr>
           <a:xfrm>
-            <a:off x="1316736" y="5641848"/>
+            <a:off x="1316736" y="5751575"/>
             <a:ext cx="1023111" cy="45720"/>
           </a:xfrm>
           <a:prstGeom prst="rect">
@@ -5999,7 +6015,7 @@
         </p:nvSpPr>
         <p:spPr>
           <a:xfrm>
-            <a:off x="1316736" y="5701284"/>
+            <a:off x="1316736" y="5811012"/>
             <a:ext cx="1737360" cy="45720"/>
           </a:xfrm>
           <a:prstGeom prst="rect">
@@ -6043,7 +6059,7 @@
         </p:nvSpPr>
         <p:spPr>
           <a:xfrm>
-            <a:off x="1316736" y="5701284"/>
+            <a:off x="1316736" y="5811012"/>
             <a:ext cx="1737360" cy="45720"/>
           </a:xfrm>
           <a:prstGeom prst="rect">
@@ -6087,7 +6103,7 @@
         </p:nvSpPr>
         <p:spPr>
           <a:xfrm>
-            <a:off x="3108960" y="5641848"/>
+            <a:off x="3108960" y="5751575"/>
             <a:ext cx="658368" cy="128016"/>
           </a:xfrm>
           <a:prstGeom prst="rect">
@@ -6126,7 +6142,7 @@
         </p:nvSpPr>
         <p:spPr>
           <a:xfrm>
-            <a:off x="512064" y="5774436"/>
+            <a:off x="512064" y="5856731"/>
             <a:ext cx="777240" cy="128016"/>
           </a:xfrm>
           <a:prstGeom prst="rect">
@@ -6165,7 +6181,7 @@
         </p:nvSpPr>
         <p:spPr>
           <a:xfrm>
-            <a:off x="1316736" y="5792724"/>
+            <a:off x="1316736" y="5875019"/>
             <a:ext cx="1737360" cy="45720"/>
           </a:xfrm>
           <a:prstGeom prst="rect">
@@ -6209,7 +6225,7 @@
         </p:nvSpPr>
         <p:spPr>
           <a:xfrm>
-            <a:off x="1316736" y="5792724"/>
+            <a:off x="1316736" y="5875019"/>
             <a:ext cx="714248" cy="45720"/>
           </a:xfrm>
           <a:prstGeom prst="rect">
@@ -6253,7 +6269,7 @@
         </p:nvSpPr>
         <p:spPr>
           <a:xfrm>
-            <a:off x="1316736" y="5852160"/>
+            <a:off x="1316736" y="5934455"/>
             <a:ext cx="1737360" cy="45720"/>
           </a:xfrm>
           <a:prstGeom prst="rect">
@@ -6297,7 +6313,7 @@
         </p:nvSpPr>
         <p:spPr>
           <a:xfrm>
-            <a:off x="1316736" y="5852160"/>
+            <a:off x="1316736" y="5934455"/>
             <a:ext cx="1283716" cy="45720"/>
           </a:xfrm>
           <a:prstGeom prst="rect">
@@ -6341,7 +6357,7 @@
         </p:nvSpPr>
         <p:spPr>
           <a:xfrm>
-            <a:off x="3108960" y="5792724"/>
+            <a:off x="3108960" y="5875019"/>
             <a:ext cx="658368" cy="128016"/>
           </a:xfrm>
           <a:prstGeom prst="rect">
@@ -6380,7 +6396,7 @@
         </p:nvSpPr>
         <p:spPr>
           <a:xfrm>
-            <a:off x="512064" y="5925312"/>
+            <a:off x="512064" y="5980175"/>
             <a:ext cx="777240" cy="128016"/>
           </a:xfrm>
           <a:prstGeom prst="rect">
@@ -6419,7 +6435,7 @@
         </p:nvSpPr>
         <p:spPr>
           <a:xfrm>
-            <a:off x="1316736" y="5943600"/>
+            <a:off x="1316736" y="5998463"/>
             <a:ext cx="1737360" cy="45720"/>
           </a:xfrm>
           <a:prstGeom prst="rect">
@@ -6463,7 +6479,7 @@
         </p:nvSpPr>
         <p:spPr>
           <a:xfrm>
-            <a:off x="1316736" y="5943600"/>
+            <a:off x="1316736" y="5998463"/>
             <a:ext cx="1216152" cy="45720"/>
           </a:xfrm>
           <a:prstGeom prst="rect">
@@ -6507,7 +6523,7 @@
         </p:nvSpPr>
         <p:spPr>
           <a:xfrm>
-            <a:off x="1316736" y="6003036"/>
+            <a:off x="1316736" y="6057899"/>
             <a:ext cx="1737360" cy="45720"/>
           </a:xfrm>
           <a:prstGeom prst="rect">
@@ -6551,7 +6567,7 @@
         </p:nvSpPr>
         <p:spPr>
           <a:xfrm>
-            <a:off x="1316736" y="6003036"/>
+            <a:off x="1316736" y="6057899"/>
             <a:ext cx="1187196" cy="45720"/>
           </a:xfrm>
           <a:prstGeom prst="rect">
@@ -6595,7 +6611,7 @@
         </p:nvSpPr>
         <p:spPr>
           <a:xfrm>
-            <a:off x="3108960" y="5943600"/>
+            <a:off x="3108960" y="5998463"/>
             <a:ext cx="658368" cy="128016"/>
           </a:xfrm>
           <a:prstGeom prst="rect">
@@ -6634,7 +6650,7 @@
         </p:nvSpPr>
         <p:spPr>
           <a:xfrm>
-            <a:off x="512064" y="6076188"/>
+            <a:off x="512064" y="6103619"/>
             <a:ext cx="777240" cy="128016"/>
           </a:xfrm>
           <a:prstGeom prst="rect">
@@ -6673,7 +6689,7 @@
         </p:nvSpPr>
         <p:spPr>
           <a:xfrm>
-            <a:off x="1316736" y="6094476"/>
+            <a:off x="1316736" y="6121907"/>
             <a:ext cx="1737360" cy="45720"/>
           </a:xfrm>
           <a:prstGeom prst="rect">
@@ -6717,7 +6733,7 @@
         </p:nvSpPr>
         <p:spPr>
           <a:xfrm>
-            <a:off x="1316736" y="6094476"/>
+            <a:off x="1316736" y="6121907"/>
             <a:ext cx="1438148" cy="45720"/>
           </a:xfrm>
           <a:prstGeom prst="rect">
@@ -6761,7 +6777,7 @@
         </p:nvSpPr>
         <p:spPr>
           <a:xfrm>
-            <a:off x="1316736" y="6153912"/>
+            <a:off x="1316736" y="6181343"/>
             <a:ext cx="1737360" cy="45720"/>
           </a:xfrm>
           <a:prstGeom prst="rect">
@@ -6805,7 +6821,7 @@
         </p:nvSpPr>
         <p:spPr>
           <a:xfrm>
-            <a:off x="1316736" y="6153912"/>
+            <a:off x="1316736" y="6181343"/>
             <a:ext cx="1322324" cy="45720"/>
           </a:xfrm>
           <a:prstGeom prst="rect">
@@ -6849,7 +6865,7 @@
         </p:nvSpPr>
         <p:spPr>
           <a:xfrm>
-            <a:off x="3108960" y="6094476"/>
+            <a:off x="3108960" y="6121907"/>
             <a:ext cx="658368" cy="128016"/>
           </a:xfrm>
           <a:prstGeom prst="rect">
@@ -6888,7 +6904,7 @@
         </p:nvSpPr>
         <p:spPr>
           <a:xfrm>
-            <a:off x="512064" y="6227064"/>
+            <a:off x="512064" y="6227063"/>
             <a:ext cx="777240" cy="128016"/>
           </a:xfrm>
           <a:prstGeom prst="rect">
@@ -6927,7 +6943,7 @@
         </p:nvSpPr>
         <p:spPr>
           <a:xfrm>
-            <a:off x="1316736" y="6245352"/>
+            <a:off x="1316736" y="6245351"/>
             <a:ext cx="1737360" cy="45720"/>
           </a:xfrm>
           <a:prstGeom prst="rect">
@@ -6971,7 +6987,7 @@
         </p:nvSpPr>
         <p:spPr>
           <a:xfrm>
-            <a:off x="1316736" y="6245352"/>
+            <a:off x="1316736" y="6245351"/>
             <a:ext cx="1351280" cy="45720"/>
           </a:xfrm>
           <a:prstGeom prst="rect">
@@ -7015,7 +7031,7 @@
         </p:nvSpPr>
         <p:spPr>
           <a:xfrm>
-            <a:off x="1316736" y="6304788"/>
+            <a:off x="1316736" y="6304787"/>
             <a:ext cx="1737360" cy="45720"/>
           </a:xfrm>
           <a:prstGeom prst="rect">
@@ -7059,7 +7075,7 @@
         </p:nvSpPr>
         <p:spPr>
           <a:xfrm>
-            <a:off x="1316736" y="6304788"/>
+            <a:off x="1316736" y="6304787"/>
             <a:ext cx="559816" cy="45720"/>
           </a:xfrm>
           <a:prstGeom prst="rect">
@@ -7103,7 +7119,7 @@
         </p:nvSpPr>
         <p:spPr>
           <a:xfrm>
-            <a:off x="3108960" y="6245352"/>
+            <a:off x="3108960" y="6245351"/>
             <a:ext cx="658368" cy="128016"/>
           </a:xfrm>
           <a:prstGeom prst="rect">
@@ -9658,7 +9674,7 @@
                 </a:solidFill>
                 <a:latin typeface="Arial"/>
               </a:rPr>
-              <a:t>Regression vs. phase detection</a:t>
+              <a:t>Detection gap, remedy, deployment</a:t>
             </a:r>
           </a:p>
         </p:txBody>
@@ -11918,7 +11934,7 @@
         <p:spPr>
           <a:xfrm>
             <a:off x="8421624" y="4133087"/>
-            <a:ext cx="3383280" cy="969264"/>
+            <a:ext cx="3383280" cy="694944"/>
           </a:xfrm>
           <a:prstGeom prst="roundRect">
             <a:avLst>
@@ -11965,7 +11981,7 @@
         </p:nvSpPr>
         <p:spPr>
           <a:xfrm>
-            <a:off x="8540496" y="4197096"/>
+            <a:off x="8540496" y="4187952"/>
             <a:ext cx="3145536" cy="182880"/>
           </a:xfrm>
           <a:prstGeom prst="rect">
@@ -11991,7 +12007,7 @@
                 </a:solidFill>
                 <a:latin typeface="Arial"/>
               </a:rPr>
-              <a:t>Robust to the presence threshold</a:t>
+              <a:t>Gap persists at 10⁻⁴ / 10⁻³ / 10⁻²</a:t>
             </a:r>
           </a:p>
         </p:txBody>
@@ -12004,7 +12020,7 @@
         </p:nvSpPr>
         <p:spPr>
           <a:xfrm>
-            <a:off x="8558784" y="4425696"/>
+            <a:off x="8558784" y="4407408"/>
             <a:ext cx="402336" cy="182880"/>
           </a:xfrm>
           <a:prstGeom prst="roundRect">
@@ -12052,7 +12068,7 @@
         </p:nvSpPr>
         <p:spPr>
           <a:xfrm>
-            <a:off x="8558784" y="4439412"/>
+            <a:off x="8558784" y="4421124"/>
             <a:ext cx="402336" cy="155448"/>
           </a:xfrm>
           <a:prstGeom prst="rect">
@@ -12091,7 +12107,7 @@
         </p:nvSpPr>
         <p:spPr>
           <a:xfrm>
-            <a:off x="9034272" y="4425696"/>
+            <a:off x="9034272" y="4407408"/>
             <a:ext cx="402336" cy="182880"/>
           </a:xfrm>
           <a:prstGeom prst="roundRect">
@@ -12139,7 +12155,7 @@
         </p:nvSpPr>
         <p:spPr>
           <a:xfrm>
-            <a:off x="9034272" y="4439412"/>
+            <a:off x="9034272" y="4421124"/>
             <a:ext cx="402336" cy="155448"/>
           </a:xfrm>
           <a:prstGeom prst="rect">
@@ -12178,7 +12194,7 @@
         </p:nvSpPr>
         <p:spPr>
           <a:xfrm>
-            <a:off x="9509760" y="4425696"/>
+            <a:off x="9509760" y="4407408"/>
             <a:ext cx="402336" cy="182880"/>
           </a:xfrm>
           <a:prstGeom prst="roundRect">
@@ -12226,7 +12242,7 @@
         </p:nvSpPr>
         <p:spPr>
           <a:xfrm>
-            <a:off x="9509760" y="4439412"/>
+            <a:off x="9509760" y="4421124"/>
             <a:ext cx="402336" cy="155448"/>
           </a:xfrm>
           <a:prstGeom prst="rect">
@@ -12265,7 +12281,7 @@
         </p:nvSpPr>
         <p:spPr>
           <a:xfrm>
-            <a:off x="10021824" y="4425696"/>
+            <a:off x="10021824" y="4407408"/>
             <a:ext cx="1691640" cy="182880"/>
           </a:xfrm>
           <a:prstGeom prst="rect">
@@ -12291,7 +12307,7 @@
                 </a:solidFill>
                 <a:latin typeface="Arial"/>
               </a:rPr>
-              <a:t>gap persists at all three</a:t>
+              <a:t>presence threshold</a:t>
             </a:r>
           </a:p>
         </p:txBody>
@@ -12304,8 +12320,8 @@
         </p:nvSpPr>
         <p:spPr>
           <a:xfrm>
-            <a:off x="8540496" y="4681728"/>
-            <a:ext cx="3145536" cy="274320"/>
+            <a:off x="8540496" y="4626864"/>
+            <a:ext cx="3145536" cy="146304"/>
           </a:xfrm>
           <a:prstGeom prst="rect">
             <a:avLst/>
@@ -12320,17 +12336,17 @@
           <a:p>
             <a:pPr algn="l">
               <a:lnSpc>
-                <a:spcPct val="105000"/>
+                <a:spcPct val="100000"/>
               </a:lnSpc>
             </a:pPr>
             <a:r>
-              <a:rPr sz="800" b="0" i="0">
+              <a:rPr sz="750" b="0" i="0">
                 <a:solidFill>
                   <a:srgbClr val="5B6573"/>
                 </a:solidFill>
                 <a:latin typeface="Arial"/>
               </a:rPr>
-              <a:t>although the detector ranking flips with the threshold on Fe–Cr–Mo</a:t>
+              <a:t>detector ranking flips with the threshold on Fe–Cr–Mo</a:t>
             </a:r>
           </a:p>
         </p:txBody>
@@ -12343,8 +12359,251 @@
         </p:nvSpPr>
         <p:spPr>
           <a:xfrm>
-            <a:off x="8421624" y="5212080"/>
-            <a:ext cx="3383280" cy="1060704"/>
+            <a:off x="8421624" y="4901184"/>
+            <a:ext cx="3383280" cy="768096"/>
+          </a:xfrm>
+          <a:prstGeom prst="roundRect">
+            <a:avLst>
+              <a:gd name="adj" fmla="val 8000"/>
+            </a:avLst>
+          </a:prstGeom>
+          <a:solidFill>
+            <a:srgbClr val="F7F5F9"/>
+          </a:solidFill>
+          <a:ln w="9525">
+            <a:solidFill>
+              <a:srgbClr val="5B3F8C"/>
+            </a:solidFill>
+          </a:ln>
+          <a:effectLst/>
+        </p:spPr>
+        <p:style>
+          <a:lnRef idx="1">
+            <a:schemeClr val="accent1"/>
+          </a:lnRef>
+          <a:fillRef idx="3">
+            <a:schemeClr val="accent1"/>
+          </a:fillRef>
+          <a:effectRef idx="2">
+            <a:schemeClr val="accent1"/>
+          </a:effectRef>
+          <a:fontRef idx="minor">
+            <a:schemeClr val="lt1"/>
+          </a:fontRef>
+        </p:style>
+        <p:txBody>
+          <a:bodyPr rtlCol="0" anchor="ctr"/>
+          <a:lstStyle/>
+          <a:p>
+            <a:pPr algn="ctr"/>
+          </a:p>
+        </p:txBody>
+      </p:sp>
+      <p:sp>
+        <p:nvSpPr>
+          <p:cNvPr id="225" name="TextBox 224"/>
+          <p:cNvSpPr txBox="1"/>
+          <p:nvPr/>
+        </p:nvSpPr>
+        <p:spPr>
+          <a:xfrm>
+            <a:off x="8503920" y="4956048"/>
+            <a:ext cx="182880" cy="164592"/>
+          </a:xfrm>
+          <a:prstGeom prst="rect">
+            <a:avLst/>
+          </a:prstGeom>
+          <a:noFill/>
+        </p:spPr>
+        <p:txBody>
+          <a:bodyPr wrap="square" anchor="ctr" lIns="0" rIns="0" tIns="0" bIns="0">
+            <a:noAutofit/>
+          </a:bodyPr>
+          <a:lstStyle/>
+          <a:p>
+            <a:pPr algn="ctr">
+              <a:lnSpc>
+                <a:spcPct val="100000"/>
+              </a:lnSpc>
+            </a:pPr>
+            <a:r>
+              <a:rPr sz="1100" b="1" i="0">
+                <a:solidFill>
+                  <a:srgbClr val="2E7D4F"/>
+                </a:solidFill>
+                <a:latin typeface="Arial"/>
+              </a:rPr>
+              <a:t>✓</a:t>
+            </a:r>
+          </a:p>
+        </p:txBody>
+      </p:sp>
+      <p:sp>
+        <p:nvSpPr>
+          <p:cNvPr id="226" name="TextBox 225"/>
+          <p:cNvSpPr txBox="1"/>
+          <p:nvPr/>
+        </p:nvSpPr>
+        <p:spPr>
+          <a:xfrm>
+            <a:off x="8705088" y="4956048"/>
+            <a:ext cx="3017520" cy="182880"/>
+          </a:xfrm>
+          <a:prstGeom prst="rect">
+            <a:avLst/>
+          </a:prstGeom>
+          <a:noFill/>
+        </p:spPr>
+        <p:txBody>
+          <a:bodyPr wrap="square" anchor="t" lIns="0" rIns="0" tIns="0" bIns="0">
+            <a:noAutofit/>
+          </a:bodyPr>
+          <a:lstStyle/>
+          <a:p>
+            <a:pPr algn="l">
+              <a:lnSpc>
+                <a:spcPct val="100000"/>
+              </a:lnSpc>
+            </a:pPr>
+            <a:r>
+              <a:rPr sz="950" b="1" i="0">
+                <a:solidFill>
+                  <a:srgbClr val="46306C"/>
+                </a:solidFill>
+                <a:latin typeface="Arial"/>
+              </a:rPr>
+              <a:t>Presence-gated head closes the gap</a:t>
+            </a:r>
+          </a:p>
+        </p:txBody>
+      </p:sp>
+      <p:sp>
+        <p:nvSpPr>
+          <p:cNvPr id="227" name="TextBox 226"/>
+          <p:cNvSpPr txBox="1"/>
+          <p:nvPr/>
+        </p:nvSpPr>
+        <p:spPr>
+          <a:xfrm>
+            <a:off x="8540496" y="5175504"/>
+            <a:ext cx="3145536" cy="146304"/>
+          </a:xfrm>
+          <a:prstGeom prst="rect">
+            <a:avLst/>
+          </a:prstGeom>
+          <a:noFill/>
+        </p:spPr>
+        <p:txBody>
+          <a:bodyPr wrap="square" anchor="t" lIns="0" rIns="0" tIns="0" bIns="0">
+            <a:noAutofit/>
+          </a:bodyPr>
+          <a:lstStyle/>
+          <a:p>
+            <a:pPr algn="l">
+              <a:lnSpc>
+                <a:spcPct val="100000"/>
+              </a:lnSpc>
+            </a:pPr>
+            <a:r>
+              <a:rPr sz="750" b="0" i="0">
+                <a:solidFill>
+                  <a:srgbClr val="2B2B2B"/>
+                </a:solidFill>
+                <a:latin typeface="Arial"/>
+              </a:rPr>
+              <a:t>confirmatory macro-AUPRC 0.88–0.99 on all nine systems</a:t>
+            </a:r>
+          </a:p>
+        </p:txBody>
+      </p:sp>
+      <p:sp>
+        <p:nvSpPr>
+          <p:cNvPr id="228" name="TextBox 227"/>
+          <p:cNvSpPr txBox="1"/>
+          <p:nvPr/>
+        </p:nvSpPr>
+        <p:spPr>
+          <a:xfrm>
+            <a:off x="8540496" y="5312664"/>
+            <a:ext cx="3145536" cy="146304"/>
+          </a:xfrm>
+          <a:prstGeom prst="rect">
+            <a:avLst/>
+          </a:prstGeom>
+          <a:noFill/>
+        </p:spPr>
+        <p:txBody>
+          <a:bodyPr wrap="square" anchor="t" lIns="0" rIns="0" tIns="0" bIns="0">
+            <a:noAutofit/>
+          </a:bodyPr>
+          <a:lstStyle/>
+          <a:p>
+            <a:pPr algn="l">
+              <a:lnSpc>
+                <a:spcPct val="100000"/>
+              </a:lnSpc>
+            </a:pPr>
+            <a:r>
+              <a:rPr sz="750" b="0" i="0">
+                <a:solidFill>
+                  <a:srgbClr val="2B2B2B"/>
+                </a:solidFill>
+                <a:latin typeface="Arial"/>
+              </a:rPr>
+              <a:t>beats best classical detector on 8 of 9 · ahead of forest in MAE on 9 of 9</a:t>
+            </a:r>
+          </a:p>
+        </p:txBody>
+      </p:sp>
+      <p:sp>
+        <p:nvSpPr>
+          <p:cNvPr id="229" name="TextBox 228"/>
+          <p:cNvSpPr txBox="1"/>
+          <p:nvPr/>
+        </p:nvSpPr>
+        <p:spPr>
+          <a:xfrm>
+            <a:off x="8540496" y="5449824"/>
+            <a:ext cx="3145536" cy="146304"/>
+          </a:xfrm>
+          <a:prstGeom prst="rect">
+            <a:avLst/>
+          </a:prstGeom>
+          <a:noFill/>
+        </p:spPr>
+        <p:txBody>
+          <a:bodyPr wrap="square" anchor="t" lIns="0" rIns="0" tIns="0" bIns="0">
+            <a:noAutofit/>
+          </a:bodyPr>
+          <a:lstStyle/>
+          <a:p>
+            <a:pPr algn="l">
+              <a:lnSpc>
+                <a:spcPct val="100000"/>
+              </a:lnSpc>
+            </a:pPr>
+            <a:r>
+              <a:rPr sz="750" b="0" i="0">
+                <a:solidFill>
+                  <a:srgbClr val="5B6573"/>
+                </a:solidFill>
+                <a:latin typeface="Arial"/>
+              </a:rPr>
+              <a:t>3 held-out seeds · 12–47% MAE cost on carbides</a:t>
+            </a:r>
+          </a:p>
+        </p:txBody>
+      </p:sp>
+      <p:sp>
+        <p:nvSpPr>
+          <p:cNvPr id="230" name="Rounded Rectangle 229"/>
+          <p:cNvSpPr/>
+          <p:nvPr/>
+        </p:nvSpPr>
+        <p:spPr>
+          <a:xfrm>
+            <a:off x="8421624" y="5742432"/>
+            <a:ext cx="3383280" cy="603504"/>
           </a:xfrm>
           <a:prstGeom prst="roundRect">
             <a:avLst>
@@ -12385,14 +12644,14 @@
       </p:sp>
       <p:sp>
         <p:nvSpPr>
-          <p:cNvPr id="225" name="TextBox 224"/>
+          <p:cNvPr id="231" name="TextBox 230"/>
           <p:cNvSpPr txBox="1"/>
           <p:nvPr/>
         </p:nvSpPr>
         <p:spPr>
           <a:xfrm>
-            <a:off x="8540496" y="5285232"/>
-            <a:ext cx="3145536" cy="914400"/>
+            <a:off x="8540496" y="5797296"/>
+            <a:ext cx="3145536" cy="493776"/>
           </a:xfrm>
           <a:prstGeom prst="rect">
             <a:avLst/>
@@ -12426,14 +12685,14 @@
                 </a:solidFill>
                 <a:latin typeface="Arial"/>
               </a:rPr>
-              <a:t>Low phase-fraction MAE does not imply good phase-presence detection — for alloy design, detecting a rare phase matters as much as estimating its fraction.</a:t>
+              <a:t>Low MAE does not imply good detection — and two lean-Ni screens repay their one-time cost 7–50×.</a:t>
             </a:r>
           </a:p>
         </p:txBody>
       </p:sp>
       <p:cxnSp>
         <p:nvCxnSpPr>
-          <p:cNvPr id="226" name="Connector 225"/>
+          <p:cNvPr id="232" name="Connector 231"/>
           <p:cNvCxnSpPr/>
           <p:nvPr/>
         </p:nvCxnSpPr>
@@ -12469,7 +12728,7 @@
       </p:cxnSp>
       <p:cxnSp>
         <p:nvCxnSpPr>
-          <p:cNvPr id="227" name="Connector 226"/>
+          <p:cNvPr id="233" name="Connector 232"/>
           <p:cNvCxnSpPr/>
           <p:nvPr/>
         </p:nvCxnSpPr>
@@ -12505,7 +12764,7 @@
       </p:cxnSp>
       <p:sp>
         <p:nvSpPr>
-          <p:cNvPr id="228" name="TextBox 227"/>
+          <p:cNvPr id="234" name="TextBox 233"/>
           <p:cNvSpPr txBox="1"/>
           <p:nvPr/>
         </p:nvSpPr>
@@ -12537,7 +12796,7 @@
                 </a:solidFill>
                 <a:latin typeface="Arial"/>
               </a:rPr>
-              <a:t>Fixed-protocol benchmark · 6 heads + 2 mechanism probes · 4 baselines · 5 ternary + 4 extension systems · 88,542 equilibria · seeds 42 / 123 / 2024 · negative results reported in full</a:t>
+              <a:t>Fixed-protocol benchmark · 6 heads + gated remedy + 2 mechanism probes · 4 baselines · 9 systems · 88,542 equilibria · seeds 42/123/2024 + confirmatory 1009/20260905/31337 · negative results reported in full</a:t>
             </a:r>
           </a:p>
         </p:txBody>

</xml_diff>